<commit_message>
W04 D5: a predict step before every trap's reveal, in the notebooks and at the deck's transitions
Co-Authored-By: Claude Opus 5.5 <noreply@anthropic.com>
Claude-Session: https://claude.ai/code/session_01M71s2Aai15Hcww1vRoxjrv
</commit_message>
<xml_diff>
--- a/content/W04/D5/slides/C2_W04_D05_half1_STUDENT.pptx
+++ b/content/W04/D5/slides/C2_W04_D05_half1_STUDENT.pptx
@@ -2556,7 +2556,22 @@
           </a:p>
           <a:p>
             <a:r>
-              <a:t>score, only its fit. Transition: what plus 22 and plus 4 measure.</a:t>
+              <a:t>score, only its fit. Predict before S31 appears: finance's eight weeks sit 4 percent above the</a:t>
+            </a:r>
+          </a:p>
+          <a:p>
+            <a:r>
+              <a:t>same calendar weeks of 2025; against 2025's weeks counted from Diwali, are they above or below,</a:t>
+            </a:r>
+          </a:p>
+          <a:p>
+            <a:r>
+              <a:t>and by roughly how much? Take a show of hands and write the split on the board. Transition: what</a:t>
+            </a:r>
+          </a:p>
+          <a:p>
+            <a:r>
+              <a:t>plus 22 and plus 4 measure.</a:t>
             </a:r>
           </a:p>
         </p:txBody>
@@ -2636,7 +2651,17 @@
           </a:p>
           <a:p>
             <a:r>
-              <a:t>plus 19.5 against it. Transition: how far above the forecast to plan.</a:t>
+              <a:t>plus 19.5 against it. Predict before S32 appears: should the plan book the forecast itself, less,</a:t>
+            </a:r>
+          </a:p>
+          <a:p>
+            <a:r>
+              <a:t>or more, and in about how many weeks of ten should it cover demand? Most rooms say the forecast</a:t>
+            </a:r>
+          </a:p>
+          <a:p>
+            <a:r>
+              <a:t>itself, covering half. Transition: how far above the forecast to plan.</a:t>
             </a:r>
           </a:p>
         </p:txBody>

</xml_diff>

<commit_message>
W04 D5: the concept board, built region by region on half two S1a to S1c; chapter 3 closes on the week's map; humanizer read over the decks' notes and notebook 03
Co-Authored-By: Claude Opus 5.5 <noreply@anthropic.com>
Claude-Session: https://claude.ai/code/session_01M71s2Aai15Hcww1vRoxjrv
</commit_message>
<xml_diff>
--- a/content/W04/D5/slides/C2_W04_D05_half1_STUDENT.pptx
+++ b/content/W04/D5/slides/C2_W04_D05_half1_STUDENT.pptx
@@ -796,7 +796,7 @@
           </a:p>
           <a:p>
             <a:r>
-              <a:t>Veritasium's move: the reveal follows the vote of S9. Transition: where Diwali falls in 2026.</a:t>
+              <a:t>As in a Veritasium video, the reveal follows the vote of S9. Transition: where Diwali falls in 2026.</a:t>
             </a:r>
           </a:p>
         </p:txBody>
@@ -1486,12 +1486,12 @@
           <a:lstStyle/>
           <a:p>
             <a:r>
-              <a:t>LIVE, 3 minutes. Brilliant's move: the room answers before the scoreboard. Note the tie in d is</a:t>
-            </a:r>
-          </a:p>
-          <a:p>
-            <a:r>
-              <a:t>announced, not hidden: the next slide says why. Transition: the answer.</a:t>
+              <a:t>LIVE, 3 minutes. The room answers before the scoreboard runs, as learners do on Brilliant. Option d</a:t>
+            </a:r>
+          </a:p>
+          <a:p>
+            <a:r>
+              <a:t>names the tie on purpose, and the next slide says why. Transition: the answer.</a:t>
             </a:r>
           </a:p>
         </p:txBody>
@@ -1561,7 +1561,7 @@
           <a:lstStyle/>
           <a:p>
             <a:r>
-              <a:t>LIVE, 5 minutes. Tufte's small multiples: one rule per panel on the same axes. The bot beats naive</a:t>
+              <a:t>LIVE, 5 minutes. The chart uses Tufte's small multiples, one rule per panel on the same axes. The bot beats naive</a:t>
             </a:r>
           </a:p>
           <a:p>
@@ -3216,12 +3216,22 @@
           <a:lstStyle/>
           <a:p>
             <a:r>
-              <a:t>LIVE, 3 minutes. Each stakeholder is partly right: concede the true part first. The afternoon</a:t>
-            </a:r>
-          </a:p>
-          <a:p>
-            <a:r>
-              <a:t>writes the staffing note from these three cards. Transition: lunch, then half two.</a:t>
+              <a:t>LIVE, 3 minutes. The forecast joins the week's map as the promise the plan is held to: Thursday's</a:t>
+            </a:r>
+          </a:p>
+          <a:p>
+            <a:r>
+              <a:t>time axis feeds it and Monday's guardrails bound what it may chase. Each stakeholder is partly</a:t>
+            </a:r>
+          </a:p>
+          <a:p>
+            <a:r>
+              <a:t>right, so concede the true part first; the afternoon writes the staffing note from these three</a:t>
+            </a:r>
+          </a:p>
+          <a:p>
+            <a:r>
+              <a:t>lines. Transition: lunch, then half two.</a:t>
             </a:r>
           </a:p>
         </p:txBody>
@@ -3521,7 +3531,7 @@
           <a:lstStyle/>
           <a:p>
             <a:r>
-              <a:t>LIVE, 3 minutes. 3Blue1Brown's move: the picture first, the names after. The real series has a</a:t>
+              <a:t>LIVE, 3 minutes. Show the picture first and the names after, as 3Blue1Brown does. The real series has a</a:t>
             </a:r>
           </a:p>
           <a:p>
@@ -37692,7 +37702,7 @@
                           </a:solidFill>
                           <a:latin typeface="Calibri"/>
                         </a:rPr>
-                        <a:t>The 2025 festival's 4,034 a week; a hold-out that spans a festival would settle it</a:t>
+                        <a:t>The 2025 festival's 4,034 a week; a rolling origin through that festival would settle it</a:t>
                       </a:r>
                     </a:p>
                   </a:txBody>
@@ -37830,7 +37840,7 @@
                           </a:solidFill>
                           <a:latin typeface="Calibri"/>
                         </a:rPr>
-                        <a:t>Two-wheeler sales to buyers ran at 31.5 lakh in October 2025 against 12.9 lakh in September, part of it credited to cuts in GST, India's goods and services tax (FADA, the Federation of Automobile Dealers Associations, release of 7 November 2025, checked 12 October 2026); a series with the tax change marked would settle it</a:t>
+                        <a:t>Two-wheeler retail registrations ran at 31.5 lakh in October 2025 against 12.9 lakh in September, part of it credited to cuts in GST, India's goods and services tax (FADA, the Federation of Automobile Dealers Associations, release of 7 November 2025, checked 12 October 2026); a series with the tax change marked would settle it</a:t>
                       </a:r>
                     </a:p>
                   </a:txBody>
@@ -38869,334 +38879,9 @@
           </a:p>
         </p:txBody>
       </p:sp>
-      <p:sp>
-        <p:nvSpPr>
-          <p:cNvPr id="9" name="Rounded Rectangle 8"/>
-          <p:cNvSpPr/>
-          <p:nvPr/>
-        </p:nvSpPr>
-        <p:spPr>
-          <a:xfrm>
-            <a:off x="530352" y="1956816"/>
-            <a:ext cx="3588410" cy="2385568"/>
-          </a:xfrm>
-          <a:prstGeom prst="roundRect">
-            <a:avLst>
-              <a:gd name="adj" fmla="val 5000"/>
-            </a:avLst>
-          </a:prstGeom>
-          <a:solidFill>
-            <a:srgbClr val="FFFFFF"/>
-          </a:solidFill>
-          <a:ln w="9525">
-            <a:solidFill>
-              <a:srgbClr val="E4E1F1"/>
-            </a:solidFill>
-          </a:ln>
-          <a:effectLst>
-            <a:outerShdw blurRad="76200" dist="19050" dir="5400000" algn="bl" rotWithShape="0">
-              <a:srgbClr val="1A0F5C">
-                <a:alpha val="12000"/>
-              </a:srgbClr>
-            </a:outerShdw>
-          </a:effectLst>
-        </p:spPr>
-        <p:style>
-          <a:lnRef idx="1">
-            <a:schemeClr val="accent1"/>
-          </a:lnRef>
-          <a:fillRef idx="3">
-            <a:schemeClr val="accent1"/>
-          </a:fillRef>
-          <a:effectRef idx="2">
-            <a:schemeClr val="accent1"/>
-          </a:effectRef>
-          <a:fontRef idx="minor">
-            <a:schemeClr val="lt1"/>
-          </a:fontRef>
-        </p:style>
-        <p:txBody>
-          <a:bodyPr rtlCol="0" anchor="ctr" wrap="square"/>
-          <a:lstStyle/>
-          <a:p>
-            <a:pPr algn="ctr"/>
-          </a:p>
-        </p:txBody>
-      </p:sp>
-      <p:sp>
-        <p:nvSpPr>
-          <p:cNvPr id="10" name="Oval 9"/>
-          <p:cNvSpPr/>
-          <p:nvPr/>
-        </p:nvSpPr>
-        <p:spPr>
-          <a:xfrm>
-            <a:off x="731519" y="2157984"/>
-            <a:ext cx="457200" cy="457200"/>
-          </a:xfrm>
-          <a:prstGeom prst="ellipse">
-            <a:avLst/>
-          </a:prstGeom>
-          <a:solidFill>
-            <a:srgbClr val="EEEAFB"/>
-          </a:solidFill>
-          <a:ln>
-            <a:noFill/>
-          </a:ln>
-          <a:effectLst/>
-        </p:spPr>
-        <p:style>
-          <a:lnRef idx="1">
-            <a:schemeClr val="accent1"/>
-          </a:lnRef>
-          <a:fillRef idx="3">
-            <a:schemeClr val="accent1"/>
-          </a:fillRef>
-          <a:effectRef idx="2">
-            <a:schemeClr val="accent1"/>
-          </a:effectRef>
-          <a:fontRef idx="minor">
-            <a:schemeClr val="lt1"/>
-          </a:fontRef>
-        </p:style>
-        <p:txBody>
-          <a:bodyPr rtlCol="0" anchor="ctr" wrap="square"/>
-          <a:lstStyle/>
-          <a:p>
-            <a:pPr algn="ctr"/>
-          </a:p>
-        </p:txBody>
-      </p:sp>
       <p:pic>
         <p:nvPicPr>
-          <p:cNvPr id="11" name="Picture 10" descr="calculator_852ec1ae1794.png"/>
-          <p:cNvPicPr>
-            <a:picLocks noChangeAspect="1"/>
-          </p:cNvPicPr>
-          <p:nvPr/>
-        </p:nvPicPr>
-        <p:blipFill>
-          <a:blip r:embed="rId4"/>
-          <a:stretch>
-            <a:fillRect/>
-          </a:stretch>
-        </p:blipFill>
-        <p:spPr>
-          <a:xfrm>
-            <a:off x="841247" y="2267712"/>
-            <a:ext cx="237744" cy="237744"/>
-          </a:xfrm>
-          <a:prstGeom prst="rect">
-            <a:avLst/>
-          </a:prstGeom>
-        </p:spPr>
-      </p:pic>
-      <p:sp>
-        <p:nvSpPr>
-          <p:cNvPr id="12" name="TextBox 11"/>
-          <p:cNvSpPr txBox="1"/>
-          <p:nvPr/>
-        </p:nvSpPr>
-        <p:spPr>
-          <a:xfrm>
-            <a:off x="731519" y="2724912"/>
-            <a:ext cx="3186074" cy="160401"/>
-          </a:xfrm>
-          <a:prstGeom prst="rect">
-            <a:avLst/>
-          </a:prstGeom>
-          <a:noFill/>
-        </p:spPr>
-        <p:txBody>
-          <a:bodyPr wrap="square" anchor="t" lIns="0" rIns="0" tIns="0" bIns="0">
-            <a:spAutoFit/>
-          </a:bodyPr>
-          <a:lstStyle/>
-          <a:p>
-            <a:pPr algn="l"/>
-            <a:r>
-              <a:rPr sz="750" b="1" i="0" spc="250">
-                <a:solidFill>
-                  <a:srgbClr val="5B3FD6"/>
-                </a:solidFill>
-                <a:latin typeface="Calibri"/>
-              </a:rPr>
-              <a:t>TO FINANCE</a:t>
-            </a:r>
-          </a:p>
-        </p:txBody>
-      </p:sp>
-      <p:sp>
-        <p:nvSpPr>
-          <p:cNvPr id="13" name="TextBox 12"/>
-          <p:cNvSpPr txBox="1"/>
-          <p:nvPr/>
-        </p:nvSpPr>
-        <p:spPr>
-          <a:xfrm>
-            <a:off x="731519" y="2962656"/>
-            <a:ext cx="3186074" cy="267716"/>
-          </a:xfrm>
-          <a:prstGeom prst="rect">
-            <a:avLst/>
-          </a:prstGeom>
-          <a:noFill/>
-        </p:spPr>
-        <p:txBody>
-          <a:bodyPr wrap="square" anchor="t" lIns="0" rIns="0" tIns="0" bIns="0">
-            <a:spAutoFit/>
-          </a:bodyPr>
-          <a:lstStyle/>
-          <a:p>
-            <a:pPr algn="l"/>
-            <a:r>
-              <a:rPr sz="1400" b="1" i="0">
-                <a:solidFill>
-                  <a:srgbClr val="1A0F5C"/>
-                </a:solidFill>
-                <a:latin typeface="Calibri"/>
-              </a:rPr>
-              <a:t>Right growth, wrong weeks</a:t>
-            </a:r>
-          </a:p>
-        </p:txBody>
-      </p:sp>
-      <p:sp>
-        <p:nvSpPr>
-          <p:cNvPr id="14" name="TextBox 13"/>
-          <p:cNvSpPr txBox="1"/>
-          <p:nvPr/>
-        </p:nvSpPr>
-        <p:spPr>
-          <a:xfrm>
-            <a:off x="731519" y="3303524"/>
-            <a:ext cx="3186074" cy="763016"/>
-          </a:xfrm>
-          <a:prstGeom prst="rect">
-            <a:avLst/>
-          </a:prstGeom>
-          <a:noFill/>
-        </p:spPr>
-        <p:txBody>
-          <a:bodyPr wrap="square" anchor="t" lIns="0" rIns="0" tIns="0" bIns="0">
-            <a:spAutoFit/>
-          </a:bodyPr>
-          <a:lstStyle/>
-          <a:p>
-            <a:pPr algn="l"/>
-            <a:r>
-              <a:rPr sz="1100" b="0" i="0">
-                <a:solidFill>
-                  <a:srgbClr val="6B6690"/>
-                </a:solidFill>
-                <a:latin typeface="Calibri"/>
-              </a:rPr>
-              <a:t>Your 4 percent is the growth two years show. Copied by calendar, it puts the peak on 5 October, before the plan's first week, and sits 308,048 shipments short.</a:t>
-            </a:r>
-          </a:p>
-        </p:txBody>
-      </p:sp>
-      <p:sp>
-        <p:nvSpPr>
-          <p:cNvPr id="15" name="Rounded Rectangle 14"/>
-          <p:cNvSpPr/>
-          <p:nvPr/>
-        </p:nvSpPr>
-        <p:spPr>
-          <a:xfrm>
-            <a:off x="4301642" y="1956816"/>
-            <a:ext cx="3588410" cy="2385568"/>
-          </a:xfrm>
-          <a:prstGeom prst="roundRect">
-            <a:avLst>
-              <a:gd name="adj" fmla="val 5000"/>
-            </a:avLst>
-          </a:prstGeom>
-          <a:solidFill>
-            <a:srgbClr val="FFFFFF"/>
-          </a:solidFill>
-          <a:ln w="9525">
-            <a:solidFill>
-              <a:srgbClr val="E4E1F1"/>
-            </a:solidFill>
-          </a:ln>
-          <a:effectLst>
-            <a:outerShdw blurRad="76200" dist="19050" dir="5400000" algn="bl" rotWithShape="0">
-              <a:srgbClr val="1A0F5C">
-                <a:alpha val="12000"/>
-              </a:srgbClr>
-            </a:outerShdw>
-          </a:effectLst>
-        </p:spPr>
-        <p:style>
-          <a:lnRef idx="1">
-            <a:schemeClr val="accent1"/>
-          </a:lnRef>
-          <a:fillRef idx="3">
-            <a:schemeClr val="accent1"/>
-          </a:fillRef>
-          <a:effectRef idx="2">
-            <a:schemeClr val="accent1"/>
-          </a:effectRef>
-          <a:fontRef idx="minor">
-            <a:schemeClr val="lt1"/>
-          </a:fontRef>
-        </p:style>
-        <p:txBody>
-          <a:bodyPr rtlCol="0" anchor="ctr" wrap="square"/>
-          <a:lstStyle/>
-          <a:p>
-            <a:pPr algn="ctr"/>
-          </a:p>
-        </p:txBody>
-      </p:sp>
-      <p:sp>
-        <p:nvSpPr>
-          <p:cNvPr id="16" name="Oval 15"/>
-          <p:cNvSpPr/>
-          <p:nvPr/>
-        </p:nvSpPr>
-        <p:spPr>
-          <a:xfrm>
-            <a:off x="4502810" y="2157984"/>
-            <a:ext cx="457200" cy="457200"/>
-          </a:xfrm>
-          <a:prstGeom prst="ellipse">
-            <a:avLst/>
-          </a:prstGeom>
-          <a:solidFill>
-            <a:srgbClr val="EEEAFB"/>
-          </a:solidFill>
-          <a:ln>
-            <a:noFill/>
-          </a:ln>
-          <a:effectLst/>
-        </p:spPr>
-        <p:style>
-          <a:lnRef idx="1">
-            <a:schemeClr val="accent1"/>
-          </a:lnRef>
-          <a:fillRef idx="3">
-            <a:schemeClr val="accent1"/>
-          </a:fillRef>
-          <a:effectRef idx="2">
-            <a:schemeClr val="accent1"/>
-          </a:effectRef>
-          <a:fontRef idx="minor">
-            <a:schemeClr val="lt1"/>
-          </a:fontRef>
-        </p:style>
-        <p:txBody>
-          <a:bodyPr rtlCol="0" anchor="ctr" wrap="square"/>
-          <a:lstStyle/>
-          <a:p>
-            <a:pPr algn="ctr"/>
-          </a:p>
-        </p:txBody>
-      </p:sp>
-      <p:pic>
-        <p:nvPicPr>
-          <p:cNvPr id="17" name="Picture 16" descr="trending-up_0f9f07881489.png"/>
+          <p:cNvPr id="9" name="mermaid diagram" descr="052451889d7f1b16.png"/>
           <p:cNvPicPr>
             <a:picLocks noChangeAspect="1"/>
           </p:cNvPicPr>
@@ -39210,8 +38895,8 @@
         </p:blipFill>
         <p:spPr>
           <a:xfrm>
-            <a:off x="4612538" y="2267712"/>
-            <a:ext cx="237744" cy="237744"/>
+            <a:off x="829168" y="1664208"/>
+            <a:ext cx="10533357" cy="3256280"/>
           </a:xfrm>
           <a:prstGeom prst="rect">
             <a:avLst/>
@@ -39220,146 +38905,59 @@
       </p:pic>
       <p:sp>
         <p:nvSpPr>
-          <p:cNvPr id="18" name="TextBox 17"/>
-          <p:cNvSpPr txBox="1"/>
-          <p:nvPr/>
-        </p:nvSpPr>
-        <p:spPr>
-          <a:xfrm>
-            <a:off x="4502810" y="2724912"/>
-            <a:ext cx="3186074" cy="160401"/>
-          </a:xfrm>
-          <a:prstGeom prst="rect">
-            <a:avLst/>
-          </a:prstGeom>
-          <a:noFill/>
-        </p:spPr>
-        <p:txBody>
-          <a:bodyPr wrap="square" anchor="t" lIns="0" rIns="0" tIns="0" bIns="0">
-            <a:spAutoFit/>
-          </a:bodyPr>
-          <a:lstStyle/>
-          <a:p>
-            <a:pPr algn="l"/>
-            <a:r>
-              <a:rPr sz="750" b="1" i="0" spc="250">
-                <a:solidFill>
-                  <a:srgbClr val="5B3FD6"/>
-                </a:solidFill>
-                <a:latin typeface="Calibri"/>
-              </a:rPr>
-              <a:t>TO THE VENDOR'S SPONSOR</a:t>
-            </a:r>
-          </a:p>
-        </p:txBody>
-      </p:sp>
-      <p:sp>
-        <p:nvSpPr>
-          <p:cNvPr id="19" name="TextBox 18"/>
-          <p:cNvSpPr txBox="1"/>
-          <p:nvPr/>
-        </p:nvSpPr>
-        <p:spPr>
-          <a:xfrm>
-            <a:off x="4502810" y="2962656"/>
-            <a:ext cx="3186074" cy="267716"/>
-          </a:xfrm>
-          <a:prstGeom prst="rect">
-            <a:avLst/>
-          </a:prstGeom>
-          <a:noFill/>
-        </p:spPr>
-        <p:txBody>
-          <a:bodyPr wrap="square" anchor="t" lIns="0" rIns="0" tIns="0" bIns="0">
-            <a:spAutoFit/>
-          </a:bodyPr>
-          <a:lstStyle/>
-          <a:p>
-            <a:pPr algn="l"/>
-            <a:r>
-              <a:rPr sz="1400" b="1" i="0">
-                <a:solidFill>
-                  <a:srgbClr val="1A0F5C"/>
-                </a:solidFill>
-                <a:latin typeface="Calibri"/>
-              </a:rPr>
-              <a:t>A fit, never a forecast</a:t>
-            </a:r>
-          </a:p>
-        </p:txBody>
-      </p:sp>
-      <p:sp>
-        <p:nvSpPr>
-          <p:cNvPr id="20" name="TextBox 19"/>
-          <p:cNvSpPr txBox="1"/>
-          <p:nvPr/>
-        </p:nvSpPr>
-        <p:spPr>
-          <a:xfrm>
-            <a:off x="4502810" y="3303524"/>
-            <a:ext cx="3186074" cy="399796"/>
-          </a:xfrm>
-          <a:prstGeom prst="rect">
-            <a:avLst/>
-          </a:prstGeom>
-          <a:noFill/>
-        </p:spPr>
-        <p:txBody>
-          <a:bodyPr wrap="square" anchor="t" lIns="0" rIns="0" tIns="0" bIns="0">
-            <a:spAutoFit/>
-          </a:bodyPr>
-          <a:lstStyle/>
-          <a:p>
-            <a:pPr algn="l"/>
-            <a:r>
-              <a:rPr sz="1100" b="0" i="0">
-                <a:solidFill>
-                  <a:srgbClr val="6B6690"/>
-                </a:solidFill>
-                <a:latin typeface="Calibri"/>
-              </a:rPr>
-              <a:t>Within 1.4 percent on history, and 16,400 a week off on thirteen weeks it never saw.</a:t>
-            </a:r>
-          </a:p>
-        </p:txBody>
-      </p:sp>
-      <p:sp>
-        <p:nvSpPr>
-          <p:cNvPr id="21" name="Rounded Rectangle 20"/>
+          <p:cNvPr id="10" name="TextBox 9"/>
+          <p:cNvSpPr txBox="1"/>
+          <p:nvPr/>
+        </p:nvSpPr>
+        <p:spPr>
+          <a:xfrm>
+            <a:off x="530352" y="4966208"/>
+            <a:ext cx="11130991" cy="1233424"/>
+          </a:xfrm>
+          <a:prstGeom prst="rect">
+            <a:avLst/>
+          </a:prstGeom>
+          <a:noFill/>
+        </p:spPr>
+        <p:txBody>
+          <a:bodyPr wrap="square" anchor="t" lIns="0" rIns="0" tIns="0" bIns="0">
+            <a:spAutoFit/>
+          </a:bodyPr>
+          <a:lstStyle/>
+          <a:p>
+            <a:r>
+              <a:rPr sz="1600" b="0" i="0">
+                <a:solidFill>
+                  <a:srgbClr val="1A1440"/>
+                </a:solidFill>
+                <a:latin typeface="Calibri"/>
+              </a:rPr>
+              <a:t>To finance: right growth, wrong weeks, since copied by calendar the 4 percent puts the peak on 5 October and sits 308,048 shipments short. To the vendor's sponsor: a fit of 1.4 percent, and 16,400 a week off on weeks it never saw. The rule: beat the bot on hidden weeks, place the festival, cover demand in 0.82 of weeks.</a:t>
+            </a:r>
+          </a:p>
+        </p:txBody>
+      </p:sp>
+      <p:sp>
+        <p:nvSpPr>
+          <p:cNvPr id="11" name="Oval 10"/>
           <p:cNvSpPr/>
           <p:nvPr/>
         </p:nvSpPr>
         <p:spPr>
           <a:xfrm>
-            <a:off x="8072932" y="1956816"/>
-            <a:ext cx="3588410" cy="2385568"/>
-          </a:xfrm>
-          <a:prstGeom prst="roundRect">
-            <a:avLst>
-              <a:gd name="adj" fmla="val 5000"/>
-            </a:avLst>
-          </a:prstGeom>
-          <a:gradFill rotWithShape="1">
-            <a:gsLst>
-              <a:gs pos="0">
-                <a:srgbClr val="2C1A86"/>
-              </a:gs>
-              <a:gs pos="100000">
-                <a:srgbClr val="1A0F5C"/>
-              </a:gs>
-            </a:gsLst>
-            <a:lin scaled="0" ang="16200000"/>
-          </a:gradFill>
+            <a:off x="530352" y="6492240"/>
+            <a:ext cx="64008" cy="64008"/>
+          </a:xfrm>
+          <a:prstGeom prst="ellipse">
+            <a:avLst/>
+          </a:prstGeom>
+          <a:solidFill>
+            <a:srgbClr val="CFC9EE"/>
+          </a:solidFill>
           <a:ln>
             <a:noFill/>
           </a:ln>
-          <a:effectLst>
-            <a:outerShdw blurRad="76200" dist="19050" dir="5400000" algn="bl" rotWithShape="0">
-              <a:srgbClr val="1A0F5C">
-                <a:alpha val="12000"/>
-              </a:srgbClr>
-            </a:outerShdw>
-          </a:effectLst>
+          <a:effectLst/>
         </p:spPr>
         <p:style>
           <a:lnRef idx="1">
@@ -39385,14 +38983,128 @@
       </p:sp>
       <p:sp>
         <p:nvSpPr>
-          <p:cNvPr id="22" name="Oval 21"/>
+          <p:cNvPr id="12" name="TextBox 11"/>
+          <p:cNvSpPr txBox="1"/>
+          <p:nvPr/>
+        </p:nvSpPr>
+        <p:spPr>
+          <a:xfrm>
+            <a:off x="640080" y="6437376"/>
+            <a:ext cx="1608486" cy="152146"/>
+          </a:xfrm>
+          <a:prstGeom prst="rect">
+            <a:avLst/>
+          </a:prstGeom>
+          <a:noFill/>
+        </p:spPr>
+        <p:txBody>
+          <a:bodyPr wrap="square" anchor="t" lIns="0" rIns="0" tIns="0" bIns="0">
+            <a:spAutoFit/>
+          </a:bodyPr>
+          <a:lstStyle/>
+          <a:p>
+            <a:pPr algn="l"/>
+            <a:r>
+              <a:rPr sz="700" b="0" i="0">
+                <a:solidFill>
+                  <a:srgbClr val="6B6690"/>
+                </a:solidFill>
+                <a:latin typeface="Calibri"/>
+              </a:rPr>
+              <a:t>What shape do the weeks have?</a:t>
+            </a:r>
+          </a:p>
+        </p:txBody>
+      </p:sp>
+      <p:sp>
+        <p:nvSpPr>
+          <p:cNvPr id="13" name="Oval 12"/>
           <p:cNvSpPr/>
           <p:nvPr/>
         </p:nvSpPr>
         <p:spPr>
           <a:xfrm>
-            <a:off x="8274100" y="2157984"/>
-            <a:ext cx="457200" cy="457200"/>
+            <a:off x="2340006" y="6492240"/>
+            <a:ext cx="64008" cy="64008"/>
+          </a:xfrm>
+          <a:prstGeom prst="ellipse">
+            <a:avLst/>
+          </a:prstGeom>
+          <a:solidFill>
+            <a:srgbClr val="CFC9EE"/>
+          </a:solidFill>
+          <a:ln>
+            <a:noFill/>
+          </a:ln>
+          <a:effectLst/>
+        </p:spPr>
+        <p:style>
+          <a:lnRef idx="1">
+            <a:schemeClr val="accent1"/>
+          </a:lnRef>
+          <a:fillRef idx="3">
+            <a:schemeClr val="accent1"/>
+          </a:fillRef>
+          <a:effectRef idx="2">
+            <a:schemeClr val="accent1"/>
+          </a:effectRef>
+          <a:fontRef idx="minor">
+            <a:schemeClr val="lt1"/>
+          </a:fontRef>
+        </p:style>
+        <p:txBody>
+          <a:bodyPr rtlCol="0" anchor="ctr" wrap="square"/>
+          <a:lstStyle/>
+          <a:p>
+            <a:pPr algn="ctr"/>
+          </a:p>
+        </p:txBody>
+      </p:sp>
+      <p:sp>
+        <p:nvSpPr>
+          <p:cNvPr id="14" name="TextBox 13"/>
+          <p:cNvSpPr txBox="1"/>
+          <p:nvPr/>
+        </p:nvSpPr>
+        <p:spPr>
+          <a:xfrm>
+            <a:off x="2449734" y="6437376"/>
+            <a:ext cx="1746504" cy="152146"/>
+          </a:xfrm>
+          <a:prstGeom prst="rect">
+            <a:avLst/>
+          </a:prstGeom>
+          <a:noFill/>
+        </p:spPr>
+        <p:txBody>
+          <a:bodyPr wrap="square" anchor="t" lIns="0" rIns="0" tIns="0" bIns="0">
+            <a:spAutoFit/>
+          </a:bodyPr>
+          <a:lstStyle/>
+          <a:p>
+            <a:pPr algn="l"/>
+            <a:r>
+              <a:rPr sz="700" b="0" i="0">
+                <a:solidFill>
+                  <a:srgbClr val="6B6690"/>
+                </a:solidFill>
+                <a:latin typeface="Calibri"/>
+              </a:rPr>
+              <a:t>Which rule wins on hidden weeks?</a:t>
+            </a:r>
+          </a:p>
+        </p:txBody>
+      </p:sp>
+      <p:sp>
+        <p:nvSpPr>
+          <p:cNvPr id="15" name="Oval 14"/>
+          <p:cNvSpPr/>
+          <p:nvPr/>
+        </p:nvSpPr>
+        <p:spPr>
+          <a:xfrm>
+            <a:off x="4287678" y="6492240"/>
+            <a:ext cx="64008" cy="64008"/>
           </a:xfrm>
           <a:prstGeom prst="ellipse">
             <a:avLst/>
@@ -39427,340 +39139,9 @@
           </a:p>
         </p:txBody>
       </p:sp>
-      <p:pic>
-        <p:nvPicPr>
-          <p:cNvPr id="23" name="Picture 22" descr="badge-check_df01016c75a5.png"/>
-          <p:cNvPicPr>
-            <a:picLocks noChangeAspect="1"/>
-          </p:cNvPicPr>
-          <p:nvPr/>
-        </p:nvPicPr>
-        <p:blipFill>
-          <a:blip r:embed="rId6"/>
-          <a:stretch>
-            <a:fillRect/>
-          </a:stretch>
-        </p:blipFill>
-        <p:spPr>
-          <a:xfrm>
-            <a:off x="8383828" y="2267712"/>
-            <a:ext cx="237744" cy="237744"/>
-          </a:xfrm>
-          <a:prstGeom prst="rect">
-            <a:avLst/>
-          </a:prstGeom>
-        </p:spPr>
-      </p:pic>
-      <p:sp>
-        <p:nvSpPr>
-          <p:cNvPr id="24" name="TextBox 23"/>
-          <p:cNvSpPr txBox="1"/>
-          <p:nvPr/>
-        </p:nvSpPr>
-        <p:spPr>
-          <a:xfrm>
-            <a:off x="8274100" y="2724912"/>
-            <a:ext cx="3186074" cy="160401"/>
-          </a:xfrm>
-          <a:prstGeom prst="rect">
-            <a:avLst/>
-          </a:prstGeom>
-          <a:noFill/>
-        </p:spPr>
-        <p:txBody>
-          <a:bodyPr wrap="square" anchor="t" lIns="0" rIns="0" tIns="0" bIns="0">
-            <a:spAutoFit/>
-          </a:bodyPr>
-          <a:lstStyle/>
-          <a:p>
-            <a:pPr algn="l"/>
-            <a:r>
-              <a:rPr sz="750" b="1" i="0" spc="250">
-                <a:solidFill>
-                  <a:srgbClr val="D9A7FF"/>
-                </a:solidFill>
-                <a:latin typeface="Calibri"/>
-              </a:rPr>
-              <a:t>THE RULE</a:t>
-            </a:r>
-          </a:p>
-        </p:txBody>
-      </p:sp>
-      <p:sp>
-        <p:nvSpPr>
-          <p:cNvPr id="25" name="TextBox 24"/>
-          <p:cNvSpPr txBox="1"/>
-          <p:nvPr/>
-        </p:nvSpPr>
-        <p:spPr>
-          <a:xfrm>
-            <a:off x="8274100" y="2962656"/>
-            <a:ext cx="3186074" cy="498856"/>
-          </a:xfrm>
-          <a:prstGeom prst="rect">
-            <a:avLst/>
-          </a:prstGeom>
-          <a:noFill/>
-        </p:spPr>
-        <p:txBody>
-          <a:bodyPr wrap="square" anchor="t" lIns="0" rIns="0" tIns="0" bIns="0">
-            <a:spAutoFit/>
-          </a:bodyPr>
-          <a:lstStyle/>
-          <a:p>
-            <a:pPr algn="l"/>
-            <a:r>
-              <a:rPr sz="1400" b="1" i="0">
-                <a:solidFill>
-                  <a:srgbClr val="FFFFFF"/>
-                </a:solidFill>
-                <a:latin typeface="Calibri"/>
-              </a:rPr>
-              <a:t>Beat the bot, then place the festival</a:t>
-            </a:r>
-          </a:p>
-        </p:txBody>
-      </p:sp>
-      <p:sp>
-        <p:nvSpPr>
-          <p:cNvPr id="26" name="TextBox 25"/>
-          <p:cNvSpPr txBox="1"/>
-          <p:nvPr/>
-        </p:nvSpPr>
-        <p:spPr>
-          <a:xfrm>
-            <a:off x="8274100" y="3534664"/>
-            <a:ext cx="3186074" cy="581406"/>
-          </a:xfrm>
-          <a:prstGeom prst="rect">
-            <a:avLst/>
-          </a:prstGeom>
-          <a:noFill/>
-        </p:spPr>
-        <p:txBody>
-          <a:bodyPr wrap="square" anchor="t" lIns="0" rIns="0" tIns="0" bIns="0">
-            <a:spAutoFit/>
-          </a:bodyPr>
-          <a:lstStyle/>
-          <a:p>
-            <a:pPr algn="l"/>
-            <a:r>
-              <a:rPr sz="1100" b="0" i="0">
-                <a:solidFill>
-                  <a:srgbClr val="CFC9EE"/>
-                </a:solidFill>
-                <a:latin typeface="Calibri"/>
-              </a:rPr>
-              <a:t>Score on hidden weeks in shipments and rupees; copy by distance from Diwali; cover demand in 0.82 of weeks.</a:t>
-            </a:r>
-          </a:p>
-        </p:txBody>
-      </p:sp>
-      <p:sp>
-        <p:nvSpPr>
-          <p:cNvPr id="27" name="Oval 26"/>
-          <p:cNvSpPr/>
-          <p:nvPr/>
-        </p:nvSpPr>
-        <p:spPr>
-          <a:xfrm>
-            <a:off x="530352" y="6492240"/>
-            <a:ext cx="64008" cy="64008"/>
-          </a:xfrm>
-          <a:prstGeom prst="ellipse">
-            <a:avLst/>
-          </a:prstGeom>
-          <a:solidFill>
-            <a:srgbClr val="CFC9EE"/>
-          </a:solidFill>
-          <a:ln>
-            <a:noFill/>
-          </a:ln>
-          <a:effectLst/>
-        </p:spPr>
-        <p:style>
-          <a:lnRef idx="1">
-            <a:schemeClr val="accent1"/>
-          </a:lnRef>
-          <a:fillRef idx="3">
-            <a:schemeClr val="accent1"/>
-          </a:fillRef>
-          <a:effectRef idx="2">
-            <a:schemeClr val="accent1"/>
-          </a:effectRef>
-          <a:fontRef idx="minor">
-            <a:schemeClr val="lt1"/>
-          </a:fontRef>
-        </p:style>
-        <p:txBody>
-          <a:bodyPr rtlCol="0" anchor="ctr" wrap="square"/>
-          <a:lstStyle/>
-          <a:p>
-            <a:pPr algn="ctr"/>
-          </a:p>
-        </p:txBody>
-      </p:sp>
-      <p:sp>
-        <p:nvSpPr>
-          <p:cNvPr id="28" name="TextBox 27"/>
-          <p:cNvSpPr txBox="1"/>
-          <p:nvPr/>
-        </p:nvSpPr>
-        <p:spPr>
-          <a:xfrm>
-            <a:off x="640080" y="6437376"/>
-            <a:ext cx="1608486" cy="152146"/>
-          </a:xfrm>
-          <a:prstGeom prst="rect">
-            <a:avLst/>
-          </a:prstGeom>
-          <a:noFill/>
-        </p:spPr>
-        <p:txBody>
-          <a:bodyPr wrap="square" anchor="t" lIns="0" rIns="0" tIns="0" bIns="0">
-            <a:spAutoFit/>
-          </a:bodyPr>
-          <a:lstStyle/>
-          <a:p>
-            <a:pPr algn="l"/>
-            <a:r>
-              <a:rPr sz="700" b="0" i="0">
-                <a:solidFill>
-                  <a:srgbClr val="6B6690"/>
-                </a:solidFill>
-                <a:latin typeface="Calibri"/>
-              </a:rPr>
-              <a:t>What shape do the weeks have?</a:t>
-            </a:r>
-          </a:p>
-        </p:txBody>
-      </p:sp>
-      <p:sp>
-        <p:nvSpPr>
-          <p:cNvPr id="29" name="Oval 28"/>
-          <p:cNvSpPr/>
-          <p:nvPr/>
-        </p:nvSpPr>
-        <p:spPr>
-          <a:xfrm>
-            <a:off x="2340006" y="6492240"/>
-            <a:ext cx="64008" cy="64008"/>
-          </a:xfrm>
-          <a:prstGeom prst="ellipse">
-            <a:avLst/>
-          </a:prstGeom>
-          <a:solidFill>
-            <a:srgbClr val="CFC9EE"/>
-          </a:solidFill>
-          <a:ln>
-            <a:noFill/>
-          </a:ln>
-          <a:effectLst/>
-        </p:spPr>
-        <p:style>
-          <a:lnRef idx="1">
-            <a:schemeClr val="accent1"/>
-          </a:lnRef>
-          <a:fillRef idx="3">
-            <a:schemeClr val="accent1"/>
-          </a:fillRef>
-          <a:effectRef idx="2">
-            <a:schemeClr val="accent1"/>
-          </a:effectRef>
-          <a:fontRef idx="minor">
-            <a:schemeClr val="lt1"/>
-          </a:fontRef>
-        </p:style>
-        <p:txBody>
-          <a:bodyPr rtlCol="0" anchor="ctr" wrap="square"/>
-          <a:lstStyle/>
-          <a:p>
-            <a:pPr algn="ctr"/>
-          </a:p>
-        </p:txBody>
-      </p:sp>
-      <p:sp>
-        <p:nvSpPr>
-          <p:cNvPr id="30" name="TextBox 29"/>
-          <p:cNvSpPr txBox="1"/>
-          <p:nvPr/>
-        </p:nvSpPr>
-        <p:spPr>
-          <a:xfrm>
-            <a:off x="2449734" y="6437376"/>
-            <a:ext cx="1746504" cy="152146"/>
-          </a:xfrm>
-          <a:prstGeom prst="rect">
-            <a:avLst/>
-          </a:prstGeom>
-          <a:noFill/>
-        </p:spPr>
-        <p:txBody>
-          <a:bodyPr wrap="square" anchor="t" lIns="0" rIns="0" tIns="0" bIns="0">
-            <a:spAutoFit/>
-          </a:bodyPr>
-          <a:lstStyle/>
-          <a:p>
-            <a:pPr algn="l"/>
-            <a:r>
-              <a:rPr sz="700" b="0" i="0">
-                <a:solidFill>
-                  <a:srgbClr val="6B6690"/>
-                </a:solidFill>
-                <a:latin typeface="Calibri"/>
-              </a:rPr>
-              <a:t>Which rule wins on hidden weeks?</a:t>
-            </a:r>
-          </a:p>
-        </p:txBody>
-      </p:sp>
-      <p:sp>
-        <p:nvSpPr>
-          <p:cNvPr id="31" name="Oval 30"/>
-          <p:cNvSpPr/>
-          <p:nvPr/>
-        </p:nvSpPr>
-        <p:spPr>
-          <a:xfrm>
-            <a:off x="4287678" y="6492240"/>
-            <a:ext cx="64008" cy="64008"/>
-          </a:xfrm>
-          <a:prstGeom prst="ellipse">
-            <a:avLst/>
-          </a:prstGeom>
-          <a:solidFill>
-            <a:srgbClr val="5B3FD6"/>
-          </a:solidFill>
-          <a:ln>
-            <a:noFill/>
-          </a:ln>
-          <a:effectLst/>
-        </p:spPr>
-        <p:style>
-          <a:lnRef idx="1">
-            <a:schemeClr val="accent1"/>
-          </a:lnRef>
-          <a:fillRef idx="3">
-            <a:schemeClr val="accent1"/>
-          </a:fillRef>
-          <a:effectRef idx="2">
-            <a:schemeClr val="accent1"/>
-          </a:effectRef>
-          <a:fontRef idx="minor">
-            <a:schemeClr val="lt1"/>
-          </a:fontRef>
-        </p:style>
-        <p:txBody>
-          <a:bodyPr rtlCol="0" anchor="ctr" wrap="square"/>
-          <a:lstStyle/>
-          <a:p>
-            <a:pPr algn="ctr"/>
-          </a:p>
-        </p:txBody>
-      </p:sp>
-      <p:sp>
-        <p:nvSpPr>
-          <p:cNvPr id="32" name="TextBox 31"/>
+      <p:sp>
+        <p:nvSpPr>
+          <p:cNvPr id="16" name="TextBox 15"/>
           <p:cNvSpPr txBox="1"/>
           <p:nvPr/>
         </p:nvSpPr>
@@ -39795,7 +39176,7 @@
       </p:sp>
       <p:sp>
         <p:nvSpPr>
-          <p:cNvPr id="33" name="TextBox 32"/>
+          <p:cNvPr id="17" name="TextBox 16"/>
           <p:cNvSpPr txBox="1"/>
           <p:nvPr/>
         </p:nvSpPr>

</xml_diff>